<commit_message>
feat: full MassaPro rebrand of Enterprise brochure with brand book applied (purple palette, value-prop messaging, image recoloring)
</commit_message>
<xml_diff>
--- a/public/downloads/Massapro-Enterprise-Brochure-Rebranded-Compact.pptx
+++ b/public/downloads/Massapro-Enterprise-Brochure-Rebranded-Compact.pptx
@@ -1659,113 +1659,6 @@
           </a:p>
         </p:txBody>
       </p:sp>
-      <p:sp>
-        <p:nvSpPr>
-          <p:cNvPr id="5" name="Rounded Rectangle 4"/>
-          <p:cNvSpPr/>
-          <p:nvPr/>
-        </p:nvSpPr>
-        <p:spPr>
-          <a:xfrm>
-            <a:off x="7543800" y="109728"/>
-            <a:ext cx="1463040" cy="320040"/>
-          </a:xfrm>
-          <a:prstGeom prst="roundRect">
-            <a:avLst/>
-          </a:prstGeom>
-          <a:solidFill>
-            <a:srgbClr val="FFFFFF"/>
-          </a:solidFill>
-          <a:ln w="12700">
-            <a:solidFill>
-              <a:srgbClr val="7C3AED"/>
-            </a:solidFill>
-          </a:ln>
-          <a:effectLst/>
-        </p:spPr>
-        <p:style>
-          <a:lnRef idx="1">
-            <a:schemeClr val="accent1"/>
-          </a:lnRef>
-          <a:fillRef idx="3">
-            <a:schemeClr val="accent1"/>
-          </a:fillRef>
-          <a:effectRef idx="2">
-            <a:schemeClr val="accent1"/>
-          </a:effectRef>
-          <a:fontRef idx="minor">
-            <a:schemeClr val="lt1"/>
-          </a:fontRef>
-        </p:style>
-        <p:txBody>
-          <a:bodyPr rtlCol="0" anchor="ctr" tIns="0" bIns="0"/>
-          <a:lstStyle/>
-          <a:p>
-            <a:pPr algn="ctr"/>
-            <a:r>
-              <a:rPr sz="1100" b="1">
-                <a:solidFill>
-                  <a:srgbClr val="7C3AED"/>
-                </a:solidFill>
-                <a:latin typeface="Inter"/>
-              </a:rPr>
-              <a:t>MassaPro</a:t>
-            </a:r>
-          </a:p>
-        </p:txBody>
-      </p:sp>
-      <p:sp>
-        <p:nvSpPr>
-          <p:cNvPr id="6" name="Rectangle 5"/>
-          <p:cNvSpPr/>
-          <p:nvPr/>
-        </p:nvSpPr>
-        <p:spPr>
-          <a:xfrm>
-            <a:off x="7616952" y="187452"/>
-            <a:ext cx="164592" cy="164592"/>
-          </a:xfrm>
-          <a:prstGeom prst="rect">
-            <a:avLst/>
-          </a:prstGeom>
-          <a:solidFill>
-            <a:srgbClr val="7C3AED"/>
-          </a:solidFill>
-          <a:ln>
-            <a:noFill/>
-          </a:ln>
-        </p:spPr>
-        <p:style>
-          <a:lnRef idx="1">
-            <a:schemeClr val="accent1"/>
-          </a:lnRef>
-          <a:fillRef idx="3">
-            <a:schemeClr val="accent1"/>
-          </a:fillRef>
-          <a:effectRef idx="2">
-            <a:schemeClr val="accent1"/>
-          </a:effectRef>
-          <a:fontRef idx="minor">
-            <a:schemeClr val="lt1"/>
-          </a:fontRef>
-        </p:style>
-        <p:txBody>
-          <a:bodyPr rtlCol="0" anchor="ctr"/>
-          <a:lstStyle/>
-          <a:p>
-            <a:pPr algn="ctr"/>
-            <a:r>
-              <a:rPr sz="1000" b="1">
-                <a:solidFill>
-                  <a:srgbClr val="FFFFFF"/>
-                </a:solidFill>
-                <a:latin typeface="Inter"/>
-              </a:rPr>
-              <a:t>M</a:t>
-            </a:r>
-          </a:p>
-        </p:txBody>
-      </p:sp>
     </p:spTree>
   </p:cSld>
   <p:clrMapOvr>
@@ -1821,8 +1714,8 @@
         </p:nvSpPr>
         <p:spPr>
           <a:xfrm>
-            <a:off x="7543800" y="109728"/>
-            <a:ext cx="1463040" cy="320040"/>
+            <a:off x="7589520" y="109728"/>
+            <a:ext cx="1417320" cy="292608"/>
           </a:xfrm>
           <a:prstGeom prst="roundRect">
             <a:avLst/>
@@ -1876,7 +1769,7 @@
         </p:nvSpPr>
         <p:spPr>
           <a:xfrm>
-            <a:off x="7616952" y="187452"/>
+            <a:off x="7662672" y="173736"/>
             <a:ext cx="164592" cy="164592"/>
           </a:xfrm>
           <a:prstGeom prst="rect">
@@ -1975,8 +1868,8 @@
         </p:nvSpPr>
         <p:spPr>
           <a:xfrm>
-            <a:off x="7543800" y="109728"/>
-            <a:ext cx="1463040" cy="320040"/>
+            <a:off x="7589520" y="109728"/>
+            <a:ext cx="1417320" cy="292608"/>
           </a:xfrm>
           <a:prstGeom prst="roundRect">
             <a:avLst/>
@@ -2030,7 +1923,7 @@
         </p:nvSpPr>
         <p:spPr>
           <a:xfrm>
-            <a:off x="7616952" y="187452"/>
+            <a:off x="7662672" y="173736"/>
             <a:ext cx="164592" cy="164592"/>
           </a:xfrm>
           <a:prstGeom prst="rect">
@@ -2129,8 +2022,8 @@
         </p:nvSpPr>
         <p:spPr>
           <a:xfrm>
-            <a:off x="7543800" y="109728"/>
-            <a:ext cx="1463040" cy="320040"/>
+            <a:off x="7589520" y="109728"/>
+            <a:ext cx="1417320" cy="292608"/>
           </a:xfrm>
           <a:prstGeom prst="roundRect">
             <a:avLst/>
@@ -2184,7 +2077,7 @@
         </p:nvSpPr>
         <p:spPr>
           <a:xfrm>
-            <a:off x="7616952" y="187452"/>
+            <a:off x="7662672" y="173736"/>
             <a:ext cx="164592" cy="164592"/>
           </a:xfrm>
           <a:prstGeom prst="rect">
@@ -2283,8 +2176,8 @@
         </p:nvSpPr>
         <p:spPr>
           <a:xfrm>
-            <a:off x="7543800" y="109728"/>
-            <a:ext cx="1463040" cy="320040"/>
+            <a:off x="7589520" y="109728"/>
+            <a:ext cx="1417320" cy="292608"/>
           </a:xfrm>
           <a:prstGeom prst="roundRect">
             <a:avLst/>
@@ -2338,7 +2231,7 @@
         </p:nvSpPr>
         <p:spPr>
           <a:xfrm>
-            <a:off x="7616952" y="187452"/>
+            <a:off x="7662672" y="173736"/>
             <a:ext cx="164592" cy="164592"/>
           </a:xfrm>
           <a:prstGeom prst="rect">
@@ -2437,8 +2330,8 @@
         </p:nvSpPr>
         <p:spPr>
           <a:xfrm>
-            <a:off x="7543800" y="109728"/>
-            <a:ext cx="1463040" cy="320040"/>
+            <a:off x="7589520" y="109728"/>
+            <a:ext cx="1417320" cy="292608"/>
           </a:xfrm>
           <a:prstGeom prst="roundRect">
             <a:avLst/>
@@ -2492,7 +2385,7 @@
         </p:nvSpPr>
         <p:spPr>
           <a:xfrm>
-            <a:off x="7616952" y="187452"/>
+            <a:off x="7662672" y="173736"/>
             <a:ext cx="164592" cy="164592"/>
           </a:xfrm>
           <a:prstGeom prst="rect">
@@ -2591,8 +2484,8 @@
         </p:nvSpPr>
         <p:spPr>
           <a:xfrm>
-            <a:off x="7543800" y="109728"/>
-            <a:ext cx="1463040" cy="320040"/>
+            <a:off x="7589520" y="109728"/>
+            <a:ext cx="1417320" cy="292608"/>
           </a:xfrm>
           <a:prstGeom prst="roundRect">
             <a:avLst/>
@@ -2646,7 +2539,7 @@
         </p:nvSpPr>
         <p:spPr>
           <a:xfrm>
-            <a:off x="7616952" y="187452"/>
+            <a:off x="7662672" y="173736"/>
             <a:ext cx="164592" cy="164592"/>
           </a:xfrm>
           <a:prstGeom prst="rect">
@@ -2745,8 +2638,8 @@
         </p:nvSpPr>
         <p:spPr>
           <a:xfrm>
-            <a:off x="7543800" y="109728"/>
-            <a:ext cx="1463040" cy="320040"/>
+            <a:off x="7589520" y="109728"/>
+            <a:ext cx="1417320" cy="292608"/>
           </a:xfrm>
           <a:prstGeom prst="roundRect">
             <a:avLst/>
@@ -2800,7 +2693,7 @@
         </p:nvSpPr>
         <p:spPr>
           <a:xfrm>
-            <a:off x="7616952" y="187452"/>
+            <a:off x="7662672" y="173736"/>
             <a:ext cx="164592" cy="164592"/>
           </a:xfrm>
           <a:prstGeom prst="rect">
@@ -2899,8 +2792,8 @@
         </p:nvSpPr>
         <p:spPr>
           <a:xfrm>
-            <a:off x="7543800" y="109728"/>
-            <a:ext cx="1463040" cy="320040"/>
+            <a:off x="7589520" y="109728"/>
+            <a:ext cx="1417320" cy="292608"/>
           </a:xfrm>
           <a:prstGeom prst="roundRect">
             <a:avLst/>
@@ -2954,7 +2847,7 @@
         </p:nvSpPr>
         <p:spPr>
           <a:xfrm>
-            <a:off x="7616952" y="187452"/>
+            <a:off x="7662672" y="173736"/>
             <a:ext cx="164592" cy="164592"/>
           </a:xfrm>
           <a:prstGeom prst="rect">
@@ -3053,8 +2946,8 @@
         </p:nvSpPr>
         <p:spPr>
           <a:xfrm>
-            <a:off x="7543800" y="109728"/>
-            <a:ext cx="1463040" cy="320040"/>
+            <a:off x="7589520" y="109728"/>
+            <a:ext cx="1417320" cy="292608"/>
           </a:xfrm>
           <a:prstGeom prst="roundRect">
             <a:avLst/>
@@ -3108,7 +3001,7 @@
         </p:nvSpPr>
         <p:spPr>
           <a:xfrm>
-            <a:off x="7616952" y="187452"/>
+            <a:off x="7662672" y="173736"/>
             <a:ext cx="164592" cy="164592"/>
           </a:xfrm>
           <a:prstGeom prst="rect">
@@ -3207,8 +3100,8 @@
         </p:nvSpPr>
         <p:spPr>
           <a:xfrm>
-            <a:off x="7543800" y="109728"/>
-            <a:ext cx="1463040" cy="320040"/>
+            <a:off x="7589520" y="109728"/>
+            <a:ext cx="1417320" cy="292608"/>
           </a:xfrm>
           <a:prstGeom prst="roundRect">
             <a:avLst/>
@@ -3262,7 +3155,7 @@
         </p:nvSpPr>
         <p:spPr>
           <a:xfrm>
-            <a:off x="7616952" y="187452"/>
+            <a:off x="7662672" y="173736"/>
             <a:ext cx="164592" cy="164592"/>
           </a:xfrm>
           <a:prstGeom prst="rect">
@@ -5523,8 +5416,8 @@
         </p:nvSpPr>
         <p:spPr>
           <a:xfrm>
-            <a:off x="7543800" y="109728"/>
-            <a:ext cx="1463040" cy="320040"/>
+            <a:off x="7589520" y="109728"/>
+            <a:ext cx="1417320" cy="292608"/>
           </a:xfrm>
           <a:prstGeom prst="roundRect">
             <a:avLst/>
@@ -5578,7 +5471,7 @@
         </p:nvSpPr>
         <p:spPr>
           <a:xfrm>
-            <a:off x="7616952" y="187452"/>
+            <a:off x="7662672" y="173736"/>
             <a:ext cx="164592" cy="164592"/>
           </a:xfrm>
           <a:prstGeom prst="rect">
@@ -5677,8 +5570,8 @@
         </p:nvSpPr>
         <p:spPr>
           <a:xfrm>
-            <a:off x="7543800" y="109728"/>
-            <a:ext cx="1463040" cy="320040"/>
+            <a:off x="7589520" y="109728"/>
+            <a:ext cx="1417320" cy="292608"/>
           </a:xfrm>
           <a:prstGeom prst="roundRect">
             <a:avLst/>
@@ -5732,7 +5625,7 @@
         </p:nvSpPr>
         <p:spPr>
           <a:xfrm>
-            <a:off x="7616952" y="187452"/>
+            <a:off x="7662672" y="173736"/>
             <a:ext cx="164592" cy="164592"/>
           </a:xfrm>
           <a:prstGeom prst="rect">
@@ -5831,8 +5724,8 @@
         </p:nvSpPr>
         <p:spPr>
           <a:xfrm>
-            <a:off x="7543800" y="109728"/>
-            <a:ext cx="1463040" cy="320040"/>
+            <a:off x="7589520" y="109728"/>
+            <a:ext cx="1417320" cy="292608"/>
           </a:xfrm>
           <a:prstGeom prst="roundRect">
             <a:avLst/>
@@ -5886,7 +5779,7 @@
         </p:nvSpPr>
         <p:spPr>
           <a:xfrm>
-            <a:off x="7616952" y="187452"/>
+            <a:off x="7662672" y="173736"/>
             <a:ext cx="164592" cy="164592"/>
           </a:xfrm>
           <a:prstGeom prst="rect">
@@ -5985,8 +5878,8 @@
         </p:nvSpPr>
         <p:spPr>
           <a:xfrm>
-            <a:off x="7543800" y="109728"/>
-            <a:ext cx="1463040" cy="320040"/>
+            <a:off x="7589520" y="109728"/>
+            <a:ext cx="1417320" cy="292608"/>
           </a:xfrm>
           <a:prstGeom prst="roundRect">
             <a:avLst/>
@@ -6040,7 +5933,7 @@
         </p:nvSpPr>
         <p:spPr>
           <a:xfrm>
-            <a:off x="7616952" y="187452"/>
+            <a:off x="7662672" y="173736"/>
             <a:ext cx="164592" cy="164592"/>
           </a:xfrm>
           <a:prstGeom prst="rect">
@@ -6139,8 +6032,8 @@
         </p:nvSpPr>
         <p:spPr>
           <a:xfrm>
-            <a:off x="7543800" y="109728"/>
-            <a:ext cx="1463040" cy="320040"/>
+            <a:off x="7589520" y="109728"/>
+            <a:ext cx="1417320" cy="292608"/>
           </a:xfrm>
           <a:prstGeom prst="roundRect">
             <a:avLst/>
@@ -6194,7 +6087,7 @@
         </p:nvSpPr>
         <p:spPr>
           <a:xfrm>
-            <a:off x="7616952" y="187452"/>
+            <a:off x="7662672" y="173736"/>
             <a:ext cx="164592" cy="164592"/>
           </a:xfrm>
           <a:prstGeom prst="rect">
@@ -6293,8 +6186,8 @@
         </p:nvSpPr>
         <p:spPr>
           <a:xfrm>
-            <a:off x="7543800" y="109728"/>
-            <a:ext cx="1463040" cy="320040"/>
+            <a:off x="7589520" y="109728"/>
+            <a:ext cx="1417320" cy="292608"/>
           </a:xfrm>
           <a:prstGeom prst="roundRect">
             <a:avLst/>
@@ -6348,7 +6241,7 @@
         </p:nvSpPr>
         <p:spPr>
           <a:xfrm>
-            <a:off x="7616952" y="187452"/>
+            <a:off x="7662672" y="173736"/>
             <a:ext cx="164592" cy="164592"/>
           </a:xfrm>
           <a:prstGeom prst="rect">
@@ -6447,8 +6340,8 @@
         </p:nvSpPr>
         <p:spPr>
           <a:xfrm>
-            <a:off x="7543800" y="109728"/>
-            <a:ext cx="1463040" cy="320040"/>
+            <a:off x="7589520" y="109728"/>
+            <a:ext cx="1417320" cy="292608"/>
           </a:xfrm>
           <a:prstGeom prst="roundRect">
             <a:avLst/>
@@ -6502,7 +6395,7 @@
         </p:nvSpPr>
         <p:spPr>
           <a:xfrm>
-            <a:off x="7616952" y="187452"/>
+            <a:off x="7662672" y="173736"/>
             <a:ext cx="164592" cy="164592"/>
           </a:xfrm>
           <a:prstGeom prst="rect">
@@ -6601,8 +6494,8 @@
         </p:nvSpPr>
         <p:spPr>
           <a:xfrm>
-            <a:off x="7543800" y="109728"/>
-            <a:ext cx="1463040" cy="320040"/>
+            <a:off x="7589520" y="109728"/>
+            <a:ext cx="1417320" cy="292608"/>
           </a:xfrm>
           <a:prstGeom prst="roundRect">
             <a:avLst/>
@@ -6656,7 +6549,7 @@
         </p:nvSpPr>
         <p:spPr>
           <a:xfrm>
-            <a:off x="7616952" y="187452"/>
+            <a:off x="7662672" y="173736"/>
             <a:ext cx="164592" cy="164592"/>
           </a:xfrm>
           <a:prstGeom prst="rect">
@@ -6755,8 +6648,8 @@
         </p:nvSpPr>
         <p:spPr>
           <a:xfrm>
-            <a:off x="7543800" y="109728"/>
-            <a:ext cx="1463040" cy="320040"/>
+            <a:off x="7589520" y="109728"/>
+            <a:ext cx="1417320" cy="292608"/>
           </a:xfrm>
           <a:prstGeom prst="roundRect">
             <a:avLst/>
@@ -6810,7 +6703,7 @@
         </p:nvSpPr>
         <p:spPr>
           <a:xfrm>
-            <a:off x="7616952" y="187452"/>
+            <a:off x="7662672" y="173736"/>
             <a:ext cx="164592" cy="164592"/>
           </a:xfrm>
           <a:prstGeom prst="rect">
@@ -6909,8 +6802,8 @@
         </p:nvSpPr>
         <p:spPr>
           <a:xfrm>
-            <a:off x="7543800" y="109728"/>
-            <a:ext cx="1463040" cy="320040"/>
+            <a:off x="7589520" y="109728"/>
+            <a:ext cx="1417320" cy="292608"/>
           </a:xfrm>
           <a:prstGeom prst="roundRect">
             <a:avLst/>
@@ -6964,7 +6857,7 @@
         </p:nvSpPr>
         <p:spPr>
           <a:xfrm>
-            <a:off x="7616952" y="187452"/>
+            <a:off x="7662672" y="173736"/>
             <a:ext cx="164592" cy="164592"/>
           </a:xfrm>
           <a:prstGeom prst="rect">
@@ -7063,8 +6956,8 @@
         </p:nvSpPr>
         <p:spPr>
           <a:xfrm>
-            <a:off x="7543800" y="109728"/>
-            <a:ext cx="1463040" cy="320040"/>
+            <a:off x="7589520" y="109728"/>
+            <a:ext cx="1417320" cy="292608"/>
           </a:xfrm>
           <a:prstGeom prst="roundRect">
             <a:avLst/>
@@ -7118,7 +7011,7 @@
         </p:nvSpPr>
         <p:spPr>
           <a:xfrm>
-            <a:off x="7616952" y="187452"/>
+            <a:off x="7662672" y="173736"/>
             <a:ext cx="164592" cy="164592"/>
           </a:xfrm>
           <a:prstGeom prst="rect">
@@ -11916,8 +11809,8 @@
         </p:nvSpPr>
         <p:spPr>
           <a:xfrm>
-            <a:off x="7543800" y="109728"/>
-            <a:ext cx="1463040" cy="320040"/>
+            <a:off x="7589520" y="109728"/>
+            <a:ext cx="1417320" cy="292608"/>
           </a:xfrm>
           <a:prstGeom prst="roundRect">
             <a:avLst/>
@@ -11971,7 +11864,7 @@
         </p:nvSpPr>
         <p:spPr>
           <a:xfrm>
-            <a:off x="7616952" y="187452"/>
+            <a:off x="7662672" y="173736"/>
             <a:ext cx="164592" cy="164592"/>
           </a:xfrm>
           <a:prstGeom prst="rect">
@@ -12070,8 +11963,8 @@
         </p:nvSpPr>
         <p:spPr>
           <a:xfrm>
-            <a:off x="7543800" y="109728"/>
-            <a:ext cx="1463040" cy="320040"/>
+            <a:off x="7589520" y="109728"/>
+            <a:ext cx="1417320" cy="292608"/>
           </a:xfrm>
           <a:prstGeom prst="roundRect">
             <a:avLst/>
@@ -12125,7 +12018,7 @@
         </p:nvSpPr>
         <p:spPr>
           <a:xfrm>
-            <a:off x="7616952" y="187452"/>
+            <a:off x="7662672" y="173736"/>
             <a:ext cx="164592" cy="164592"/>
           </a:xfrm>
           <a:prstGeom prst="rect">
@@ -12224,8 +12117,8 @@
         </p:nvSpPr>
         <p:spPr>
           <a:xfrm>
-            <a:off x="7543800" y="109728"/>
-            <a:ext cx="1463040" cy="320040"/>
+            <a:off x="7589520" y="109728"/>
+            <a:ext cx="1417320" cy="292608"/>
           </a:xfrm>
           <a:prstGeom prst="roundRect">
             <a:avLst/>
@@ -12279,7 +12172,7 @@
         </p:nvSpPr>
         <p:spPr>
           <a:xfrm>
-            <a:off x="7616952" y="187452"/>
+            <a:off x="7662672" y="173736"/>
             <a:ext cx="164592" cy="164592"/>
           </a:xfrm>
           <a:prstGeom prst="rect">
@@ -12378,8 +12271,8 @@
         </p:nvSpPr>
         <p:spPr>
           <a:xfrm>
-            <a:off x="7543800" y="109728"/>
-            <a:ext cx="1463040" cy="320040"/>
+            <a:off x="7589520" y="109728"/>
+            <a:ext cx="1417320" cy="292608"/>
           </a:xfrm>
           <a:prstGeom prst="roundRect">
             <a:avLst/>
@@ -12433,7 +12326,7 @@
         </p:nvSpPr>
         <p:spPr>
           <a:xfrm>
-            <a:off x="7616952" y="187452"/>
+            <a:off x="7662672" y="173736"/>
             <a:ext cx="164592" cy="164592"/>
           </a:xfrm>
           <a:prstGeom prst="rect">
@@ -12532,8 +12425,8 @@
         </p:nvSpPr>
         <p:spPr>
           <a:xfrm>
-            <a:off x="7543800" y="109728"/>
-            <a:ext cx="1463040" cy="320040"/>
+            <a:off x="7589520" y="109728"/>
+            <a:ext cx="1417320" cy="292608"/>
           </a:xfrm>
           <a:prstGeom prst="roundRect">
             <a:avLst/>
@@ -12587,7 +12480,7 @@
         </p:nvSpPr>
         <p:spPr>
           <a:xfrm>
-            <a:off x="7616952" y="187452"/>
+            <a:off x="7662672" y="173736"/>
             <a:ext cx="164592" cy="164592"/>
           </a:xfrm>
           <a:prstGeom prst="rect">
@@ -12686,8 +12579,8 @@
         </p:nvSpPr>
         <p:spPr>
           <a:xfrm>
-            <a:off x="7543800" y="109728"/>
-            <a:ext cx="1463040" cy="320040"/>
+            <a:off x="7589520" y="109728"/>
+            <a:ext cx="1417320" cy="292608"/>
           </a:xfrm>
           <a:prstGeom prst="roundRect">
             <a:avLst/>
@@ -12741,7 +12634,7 @@
         </p:nvSpPr>
         <p:spPr>
           <a:xfrm>
-            <a:off x="7616952" y="187452"/>
+            <a:off x="7662672" y="173736"/>
             <a:ext cx="164592" cy="164592"/>
           </a:xfrm>
           <a:prstGeom prst="rect">
@@ -12840,8 +12733,8 @@
         </p:nvSpPr>
         <p:spPr>
           <a:xfrm>
-            <a:off x="7543800" y="109728"/>
-            <a:ext cx="1463040" cy="320040"/>
+            <a:off x="7589520" y="109728"/>
+            <a:ext cx="1417320" cy="292608"/>
           </a:xfrm>
           <a:prstGeom prst="roundRect">
             <a:avLst/>
@@ -12895,7 +12788,7 @@
         </p:nvSpPr>
         <p:spPr>
           <a:xfrm>
-            <a:off x="7616952" y="187452"/>
+            <a:off x="7662672" y="173736"/>
             <a:ext cx="164592" cy="164592"/>
           </a:xfrm>
           <a:prstGeom prst="rect">
@@ -12994,8 +12887,8 @@
         </p:nvSpPr>
         <p:spPr>
           <a:xfrm>
-            <a:off x="7543800" y="109728"/>
-            <a:ext cx="1463040" cy="320040"/>
+            <a:off x="7589520" y="109728"/>
+            <a:ext cx="1417320" cy="292608"/>
           </a:xfrm>
           <a:prstGeom prst="roundRect">
             <a:avLst/>
@@ -13049,7 +12942,7 @@
         </p:nvSpPr>
         <p:spPr>
           <a:xfrm>
-            <a:off x="7616952" y="187452"/>
+            <a:off x="7662672" y="173736"/>
             <a:ext cx="164592" cy="164592"/>
           </a:xfrm>
           <a:prstGeom prst="rect">

</xml_diff>